<commit_message>
a bunch of changes to new classes
</commit_message>
<xml_diff>
--- a/canvas/avc248/slides/week-07-portfolio.pptx
+++ b/canvas/avc248/slides/week-07-portfolio.pptx
@@ -1519,6 +1519,10 @@
           </a:solidFill>
           <a:ln/>
         </p:spPr>
+        <p:txBody>
+          <a:bodyPr/>
+          <a:p/>
+        </p:txBody>
       </p:sp>
       <p:sp>
         <p:nvSpPr>
@@ -1541,6 +1545,10 @@
           </a:solidFill>
           <a:ln/>
         </p:spPr>
+        <p:txBody>
+          <a:bodyPr/>
+          <a:p/>
+        </p:txBody>
       </p:sp>
       <p:sp>
         <p:nvSpPr>
@@ -1561,6 +1569,10 @@
           </a:solidFill>
           <a:ln/>
         </p:spPr>
+        <p:txBody>
+          <a:bodyPr/>
+          <a:p/>
+        </p:txBody>
       </p:sp>
       <p:sp>
         <p:nvSpPr>
@@ -1753,6 +1765,10 @@
           </a:solidFill>
           <a:ln/>
         </p:spPr>
+        <p:txBody>
+          <a:bodyPr/>
+          <a:p/>
+        </p:txBody>
       </p:sp>
       <p:sp>
         <p:nvSpPr>
@@ -1897,6 +1913,10 @@
             </a:outerShdw>
           </a:effectLst>
         </p:spPr>
+        <p:txBody>
+          <a:bodyPr/>
+          <a:p/>
+        </p:txBody>
       </p:sp>
       <p:sp>
         <p:nvSpPr>
@@ -1917,6 +1937,10 @@
           </a:solidFill>
           <a:ln/>
         </p:spPr>
+        <p:txBody>
+          <a:bodyPr/>
+          <a:p/>
+        </p:txBody>
       </p:sp>
       <p:sp>
         <p:nvSpPr>
@@ -1990,7 +2014,7 @@
                 <a:ea typeface="Calibri" pitchFamily="34" charset="-122"/>
                 <a:cs typeface="Calibri" pitchFamily="34" charset="-120"/>
               </a:rPr>
-              <a:t>Only the pieces you are genuinely proud of. One weak project lowers the whole set.</a:t>
+              <a:t>Only the pieces you are really proud of. One weak project lowers the whole set.</a:t>
             </a:r>
             <a:endParaRPr lang="en-US" sz="1150" dirty="0"/>
           </a:p>
@@ -2022,6 +2046,10 @@
             </a:outerShdw>
           </a:effectLst>
         </p:spPr>
+        <p:txBody>
+          <a:bodyPr/>
+          <a:p/>
+        </p:txBody>
       </p:sp>
       <p:sp>
         <p:nvSpPr>
@@ -2042,6 +2070,10 @@
           </a:solidFill>
           <a:ln/>
         </p:spPr>
+        <p:txBody>
+          <a:bodyPr/>
+          <a:p/>
+        </p:txBody>
       </p:sp>
       <p:sp>
         <p:nvSpPr>
@@ -2147,6 +2179,10 @@
             </a:outerShdw>
           </a:effectLst>
         </p:spPr>
+        <p:txBody>
+          <a:bodyPr/>
+          <a:p/>
+        </p:txBody>
       </p:sp>
       <p:sp>
         <p:nvSpPr>
@@ -2167,6 +2203,10 @@
           </a:solidFill>
           <a:ln/>
         </p:spPr>
+        <p:txBody>
+          <a:bodyPr/>
+          <a:p/>
+        </p:txBody>
       </p:sp>
       <p:sp>
         <p:nvSpPr>
@@ -2408,6 +2448,10 @@
           </a:solidFill>
           <a:ln/>
         </p:spPr>
+        <p:txBody>
+          <a:bodyPr/>
+          <a:p/>
+        </p:txBody>
       </p:sp>
       <p:sp>
         <p:nvSpPr>
@@ -2552,6 +2596,10 @@
             </a:outerShdw>
           </a:effectLst>
         </p:spPr>
+        <p:txBody>
+          <a:bodyPr/>
+          <a:p/>
+        </p:txBody>
       </p:sp>
       <p:sp>
         <p:nvSpPr>
@@ -2572,6 +2620,10 @@
           </a:solidFill>
           <a:ln/>
         </p:spPr>
+        <p:txBody>
+          <a:bodyPr/>
+          <a:p/>
+        </p:txBody>
       </p:sp>
       <p:sp>
         <p:nvSpPr>
@@ -2677,6 +2729,10 @@
             </a:outerShdw>
           </a:effectLst>
         </p:spPr>
+        <p:txBody>
+          <a:bodyPr/>
+          <a:p/>
+        </p:txBody>
       </p:sp>
       <p:sp>
         <p:nvSpPr>
@@ -2697,6 +2753,10 @@
           </a:solidFill>
           <a:ln/>
         </p:spPr>
+        <p:txBody>
+          <a:bodyPr/>
+          <a:p/>
+        </p:txBody>
       </p:sp>
       <p:sp>
         <p:nvSpPr>
@@ -2802,6 +2862,10 @@
             </a:outerShdw>
           </a:effectLst>
         </p:spPr>
+        <p:txBody>
+          <a:bodyPr/>
+          <a:p/>
+        </p:txBody>
       </p:sp>
       <p:sp>
         <p:nvSpPr>
@@ -2822,6 +2886,10 @@
           </a:solidFill>
           <a:ln/>
         </p:spPr>
+        <p:txBody>
+          <a:bodyPr/>
+          <a:p/>
+        </p:txBody>
       </p:sp>
       <p:sp>
         <p:nvSpPr>
@@ -3063,6 +3131,10 @@
           </a:solidFill>
           <a:ln/>
         </p:spPr>
+        <p:txBody>
+          <a:bodyPr/>
+          <a:p/>
+        </p:txBody>
       </p:sp>
       <p:sp>
         <p:nvSpPr>
@@ -3207,6 +3279,10 @@
             </a:outerShdw>
           </a:effectLst>
         </p:spPr>
+        <p:txBody>
+          <a:bodyPr/>
+          <a:p/>
+        </p:txBody>
       </p:sp>
       <p:sp>
         <p:nvSpPr>
@@ -3227,6 +3303,10 @@
           </a:solidFill>
           <a:ln/>
         </p:spPr>
+        <p:txBody>
+          <a:bodyPr/>
+          <a:p/>
+        </p:txBody>
       </p:sp>
       <p:sp>
         <p:nvSpPr>
@@ -3371,6 +3451,10 @@
             </a:outerShdw>
           </a:effectLst>
         </p:spPr>
+        <p:txBody>
+          <a:bodyPr/>
+          <a:p/>
+        </p:txBody>
       </p:sp>
       <p:sp>
         <p:nvSpPr>
@@ -3391,6 +3475,10 @@
           </a:solidFill>
           <a:ln/>
         </p:spPr>
+        <p:txBody>
+          <a:bodyPr/>
+          <a:p/>
+        </p:txBody>
       </p:sp>
       <p:sp>
         <p:nvSpPr>
@@ -3535,6 +3623,10 @@
             </a:outerShdw>
           </a:effectLst>
         </p:spPr>
+        <p:txBody>
+          <a:bodyPr/>
+          <a:p/>
+        </p:txBody>
       </p:sp>
       <p:sp>
         <p:nvSpPr>
@@ -3555,6 +3647,10 @@
           </a:solidFill>
           <a:ln/>
         </p:spPr>
+        <p:txBody>
+          <a:bodyPr/>
+          <a:p/>
+        </p:txBody>
       </p:sp>
       <p:sp>
         <p:nvSpPr>
@@ -3763,6 +3859,10 @@
           </a:solidFill>
           <a:ln/>
         </p:spPr>
+        <p:txBody>
+          <a:bodyPr/>
+          <a:p/>
+        </p:txBody>
       </p:sp>
       <p:sp>
         <p:nvSpPr>
@@ -3907,6 +4007,10 @@
             </a:outerShdw>
           </a:effectLst>
         </p:spPr>
+        <p:txBody>
+          <a:bodyPr/>
+          <a:p/>
+        </p:txBody>
       </p:sp>
       <p:sp>
         <p:nvSpPr>
@@ -3927,6 +4031,10 @@
           </a:solidFill>
           <a:ln/>
         </p:spPr>
+        <p:txBody>
+          <a:bodyPr/>
+          <a:p/>
+        </p:txBody>
       </p:sp>
       <p:sp>
         <p:nvSpPr>
@@ -4032,6 +4140,10 @@
             </a:outerShdw>
           </a:effectLst>
         </p:spPr>
+        <p:txBody>
+          <a:bodyPr/>
+          <a:p/>
+        </p:txBody>
       </p:sp>
       <p:sp>
         <p:nvSpPr>
@@ -4052,6 +4164,10 @@
           </a:solidFill>
           <a:ln/>
         </p:spPr>
+        <p:txBody>
+          <a:bodyPr/>
+          <a:p/>
+        </p:txBody>
       </p:sp>
       <p:sp>
         <p:nvSpPr>
@@ -4157,6 +4273,10 @@
             </a:outerShdw>
           </a:effectLst>
         </p:spPr>
+        <p:txBody>
+          <a:bodyPr/>
+          <a:p/>
+        </p:txBody>
       </p:sp>
       <p:sp>
         <p:nvSpPr>
@@ -4177,6 +4297,10 @@
           </a:solidFill>
           <a:ln/>
         </p:spPr>
+        <p:txBody>
+          <a:bodyPr/>
+          <a:p/>
+        </p:txBody>
       </p:sp>
       <p:sp>
         <p:nvSpPr>
@@ -4418,6 +4542,10 @@
           </a:solidFill>
           <a:ln/>
         </p:spPr>
+        <p:txBody>
+          <a:bodyPr/>
+          <a:p/>
+        </p:txBody>
       </p:sp>
       <p:sp>
         <p:nvSpPr>
@@ -4562,6 +4690,10 @@
             </a:outerShdw>
           </a:effectLst>
         </p:spPr>
+        <p:txBody>
+          <a:bodyPr/>
+          <a:p/>
+        </p:txBody>
       </p:sp>
       <p:sp>
         <p:nvSpPr>
@@ -4582,6 +4714,10 @@
           </a:solidFill>
           <a:ln/>
         </p:spPr>
+        <p:txBody>
+          <a:bodyPr/>
+          <a:p/>
+        </p:txBody>
       </p:sp>
       <p:sp>
         <p:nvSpPr>
@@ -4687,6 +4823,10 @@
             </a:outerShdw>
           </a:effectLst>
         </p:spPr>
+        <p:txBody>
+          <a:bodyPr/>
+          <a:p/>
+        </p:txBody>
       </p:sp>
       <p:sp>
         <p:nvSpPr>
@@ -4707,6 +4847,10 @@
           </a:solidFill>
           <a:ln/>
         </p:spPr>
+        <p:txBody>
+          <a:bodyPr/>
+          <a:p/>
+        </p:txBody>
       </p:sp>
       <p:sp>
         <p:nvSpPr>
@@ -4812,6 +4956,10 @@
             </a:outerShdw>
           </a:effectLst>
         </p:spPr>
+        <p:txBody>
+          <a:bodyPr/>
+          <a:p/>
+        </p:txBody>
       </p:sp>
       <p:sp>
         <p:nvSpPr>
@@ -4832,6 +4980,10 @@
           </a:solidFill>
           <a:ln/>
         </p:spPr>
+        <p:txBody>
+          <a:bodyPr/>
+          <a:p/>
+        </p:txBody>
       </p:sp>
       <p:sp>
         <p:nvSpPr>
@@ -4937,6 +5089,10 @@
             </a:outerShdw>
           </a:effectLst>
         </p:spPr>
+        <p:txBody>
+          <a:bodyPr/>
+          <a:p/>
+        </p:txBody>
       </p:sp>
       <p:sp>
         <p:nvSpPr>
@@ -4957,6 +5113,10 @@
           </a:solidFill>
           <a:ln/>
         </p:spPr>
+        <p:txBody>
+          <a:bodyPr/>
+          <a:p/>
+        </p:txBody>
       </p:sp>
       <p:sp>
         <p:nvSpPr>
@@ -5222,6 +5382,10 @@
           </a:solidFill>
           <a:ln/>
         </p:spPr>
+        <p:txBody>
+          <a:bodyPr/>
+          <a:p/>
+        </p:txBody>
       </p:sp>
       <p:sp>
         <p:nvSpPr>
@@ -5366,6 +5530,10 @@
             </a:outerShdw>
           </a:effectLst>
         </p:spPr>
+        <p:txBody>
+          <a:bodyPr/>
+          <a:p/>
+        </p:txBody>
       </p:sp>
       <p:sp>
         <p:nvSpPr>
@@ -5386,6 +5554,10 @@
           </a:solidFill>
           <a:ln/>
         </p:spPr>
+        <p:txBody>
+          <a:bodyPr/>
+          <a:p/>
+        </p:txBody>
       </p:sp>
       <p:sp>
         <p:nvSpPr>
@@ -5491,6 +5663,10 @@
             </a:outerShdw>
           </a:effectLst>
         </p:spPr>
+        <p:txBody>
+          <a:bodyPr/>
+          <a:p/>
+        </p:txBody>
       </p:sp>
       <p:sp>
         <p:nvSpPr>
@@ -5511,6 +5687,10 @@
           </a:solidFill>
           <a:ln/>
         </p:spPr>
+        <p:txBody>
+          <a:bodyPr/>
+          <a:p/>
+        </p:txBody>
       </p:sp>
       <p:sp>
         <p:nvSpPr>
@@ -5616,6 +5796,10 @@
             </a:outerShdw>
           </a:effectLst>
         </p:spPr>
+        <p:txBody>
+          <a:bodyPr/>
+          <a:p/>
+        </p:txBody>
       </p:sp>
       <p:sp>
         <p:nvSpPr>
@@ -5636,6 +5820,10 @@
           </a:solidFill>
           <a:ln/>
         </p:spPr>
+        <p:txBody>
+          <a:bodyPr/>
+          <a:p/>
+        </p:txBody>
       </p:sp>
       <p:sp>
         <p:nvSpPr>
@@ -5879,6 +6067,10 @@
           </a:solidFill>
           <a:ln/>
         </p:spPr>
+        <p:txBody>
+          <a:bodyPr/>
+          <a:p/>
+        </p:txBody>
       </p:sp>
       <p:sp>
         <p:nvSpPr>
@@ -5901,6 +6093,10 @@
           </a:solidFill>
           <a:ln/>
         </p:spPr>
+        <p:txBody>
+          <a:bodyPr/>
+          <a:p/>
+        </p:txBody>
       </p:sp>
       <p:sp>
         <p:nvSpPr>
@@ -5921,6 +6117,10 @@
           </a:solidFill>
           <a:ln/>
         </p:spPr>
+        <p:txBody>
+          <a:bodyPr/>
+          <a:p/>
+        </p:txBody>
       </p:sp>
       <p:sp>
         <p:nvSpPr>

</xml_diff>